<commit_message>
Enhance Lambda handler to support n8n input format and add SES alert functionality; update Terraform configuration for SES email alerts and add alert_email variable
</commit_message>
<xml_diff>
--- a/report_compilato.pptx
+++ b/report_compilato.pptx
@@ -7536,7 +7536,7 @@
                 <a:ea typeface="+mn-ea"/>
                 <a:cs typeface="+mn-cs"/>
               </a:rPr>
-              <a:t>© Value Accelerator GmbH | 29 Aprile 2026 | 1.0</a:t>
+              <a:t>© Value Accelerator GmbH |  | 1.0</a:t>
             </a:r>
             <a:r>
               <a:rPr kumimoji="0" lang="en-US" sz="800" b="0" i="0" u="none" strike="noStrike" kern="1200" cap="none" spc="0" normalizeH="0" baseline="0" noProof="1">
@@ -7622,7 +7622,7 @@
           <a:p>
             <a:r>
               <a:rPr lang="en-US" noProof="1"/>
-              <a:t>Acme S.p.A.Sales Assessment Report</a:t>
+              <a:t>Sales Assessment Report</a:t>
             </a:r>
             <a:br>
               <a:rPr lang="en-US" noProof="1"/>
@@ -7657,7 +7657,7 @@
           <a:p>
             <a:r>
               <a:rPr lang="en-US" noProof="1"/>
-              <a:t>Value Accelerator ProgramDate: 29 Aprile 2026Version: 1.0</a:t>
+              <a:t>Value Accelerator ProgramDate: Version: 1.0</a:t>
             </a:r>
             <a:br>
               <a:rPr lang="en-US" noProof="1"/>
@@ -7774,7 +7774,7 @@
                   <a:srgbClr val="000000"/>
                 </a:solidFill>
               </a:rPr>
-              <a:t>© Value Accelerator GmbH | 29 Aprile 2026 | 1.0</a:t>
+              <a:t>© Value Accelerator GmbH |  | 1.0</a:t>
             </a:r>
             <a:r>
               <a:rPr lang="en-US" noProof="1">
@@ -12388,7 +12388,7 @@
                   <a:srgbClr val="000000"/>
                 </a:solidFill>
               </a:rPr>
-              <a:t>© Value Accelerator GmbH | 29 Aprile 2026 | 1.0</a:t>
+              <a:t>© Value Accelerator GmbH |  | 1.0</a:t>
             </a:r>
             <a:r>
               <a:rPr lang="en-US" noProof="1">
@@ -16485,7 +16485,7 @@
                   <a:srgbClr val="000000"/>
                 </a:solidFill>
               </a:rPr>
-              <a:t>© Value Accelerator GmbH | 29 Aprile 2026 | 1.0</a:t>
+              <a:t>© Value Accelerator GmbH |  | 1.0</a:t>
             </a:r>
             <a:r>
               <a:rPr lang="en-US" noProof="1">
@@ -21332,7 +21332,7 @@
                 <a:ea typeface="+mn-ea"/>
                 <a:cs typeface="+mn-cs"/>
               </a:rPr>
-              <a:t>© Value Accelerator GmbH | 29 Aprile 2026 | 1.0</a:t>
+              <a:t>© Value Accelerator GmbH |  | 1.0</a:t>
             </a:r>
             <a:r>
               <a:rPr kumimoji="0" lang="en-US" sz="800" b="0" i="0" u="none" strike="noStrike" kern="1200" cap="none" spc="0" normalizeH="0" baseline="0" noProof="1">
@@ -24321,7 +24321,7 @@
                   <a:srgbClr val="000000"/>
                 </a:solidFill>
               </a:rPr>
-              <a:t>© Value Accelerator GmbH | 29 Aprile 2026 | 1.0</a:t>
+              <a:t>© Value Accelerator GmbH |  | 1.0</a:t>
             </a:r>
             <a:r>
               <a:rPr lang="en-US" noProof="1">
@@ -24577,7 +24577,7 @@
                 <a:latin typeface="Arial" pitchFamily="34" charset="0"/>
                 <a:cs typeface="Arial" pitchFamily="34" charset="-120"/>
               </a:rPr>
-              <a:t>12</a:t>
+              <a:t/>
             </a:r>
             <a:r>
               <a:rPr lang="en-US" sz="1050" i="1" dirty="0" err="1">
@@ -24687,7 +24687,7 @@
                 <a:ea typeface="Arial" pitchFamily="34" charset="-122"/>
                 <a:cs typeface="Arial" pitchFamily="34" charset="-120"/>
               </a:rPr>
-              <a:t>42</a:t>
+              <a:t/>
             </a:r>
             <a:r>
               <a:rPr lang="en-US" sz="1050" i="1" dirty="0" err="1">
@@ -24798,7 +24798,7 @@
                 <a:latin typeface="Arial" pitchFamily="34" charset="0"/>
                 <a:cs typeface="Arial" pitchFamily="34" charset="-120"/>
               </a:rPr>
-              <a:t>Q1 2026</a:t>
+              <a:t/>
             </a:r>
             <a:r>
               <a:rPr lang="en-US" sz="1050" i="1" dirty="0" err="1">
@@ -26730,7 +26730,7 @@
                   <a:srgbClr val="000000"/>
                 </a:solidFill>
               </a:rPr>
-              <a:t>© Value Accelerator GmbH | 29 Aprile 2026 | 1.0</a:t>
+              <a:t>© Value Accelerator GmbH |  | 1.0</a:t>
             </a:r>
             <a:r>
               <a:rPr lang="en-US" noProof="1">
@@ -26988,7 +26988,7 @@
                 <a:ea typeface="Arial" pitchFamily="34" charset="-122"/>
                 <a:cs typeface="Arial" pitchFamily="34" charset="-120"/>
               </a:rPr>
-              <a:t>Brand riconosciuto sul mercato nazionale</a:t>
+              <a:t>When prospects engage deeply, NUO can win because the reported win rate suggests the offer resonates when supported by personalized attention and a disciplined evaluation process.</a:t>
             </a:r>
             <a:endParaRPr lang="en-US" sz="850" dirty="0"/>
           </a:p>
@@ -27071,7 +27071,7 @@
                 <a:ea typeface="Arial" pitchFamily="34" charset="-122"/>
                 <a:cs typeface="Arial" pitchFamily="34" charset="-120"/>
               </a:rPr>
-              <a:t>Team tecnico altamente specializzato</a:t>
+              <a:t>NUO has a structured sales process that already reflects several core SaaS selling disciplines, including qualification, staged demos, technical validation, tailored offers, and trial-based risk reduction.</a:t>
             </a:r>
             <a:endParaRPr lang="en-US" sz="850" dirty="0"/>
           </a:p>
@@ -27154,7 +27154,7 @@
                 <a:ea typeface="Arial" pitchFamily="34" charset="-122"/>
                 <a:cs typeface="Arial" pitchFamily="34" charset="-120"/>
               </a:rPr>
-              <a:t>Portafoglio prodotti diversificato</a:t>
+              <a:t>The team has a clear understanding of deal-level unit economics and is willing to disqualify unprofitable opportunities, which protects margin and prevents inefficient growth.</a:t>
             </a:r>
             <a:endParaRPr lang="en-US" sz="850" dirty="0"/>
           </a:p>
@@ -27237,7 +27237,7 @@
                 <a:ea typeface="Arial" pitchFamily="34" charset="-122"/>
                 <a:cs typeface="Arial" pitchFamily="34" charset="-120"/>
               </a:rPr>
-              <a:t>Solida base clienti enterprise</a:t>
+              <a:t>NUO can combine executive-level selling with technical validation by involving Customer Success in deeper product evaluations.</a:t>
             </a:r>
             <a:endParaRPr lang="en-US" sz="850" dirty="0"/>
           </a:p>
@@ -27448,7 +27448,7 @@
                 <a:ea typeface="Arial" pitchFamily="34" charset="-122"/>
                 <a:cs typeface="Arial" pitchFamily="34" charset="-120"/>
               </a:rPr>
-              <a:t>Processi interni non ancora digitalizzati</a:t>
+              <a:t>The most acute internal weakness is sales capacity because a one-person global sales model prevents sufficient market coverage and makes revenue generation fragile.</a:t>
             </a:r>
             <a:endParaRPr lang="en-US" sz="850" dirty="0"/>
           </a:p>
@@ -27531,7 +27531,7 @@
                 <a:ea typeface="Arial" pitchFamily="34" charset="-122"/>
                 <a:cs typeface="Arial" pitchFamily="34" charset="-120"/>
               </a:rPr>
-              <a:t>Dipendenza da pochi fornitori chiave</a:t>
+              <a:t>The selling motion is overly reliant on individualized seller expertise, making it difficult for other Vector reps to sell NUO consistently or confidently.</a:t>
             </a:r>
             <a:endParaRPr lang="en-US" sz="850" dirty="0"/>
           </a:p>
@@ -27614,7 +27614,7 @@
                 <a:ea typeface="Arial" pitchFamily="34" charset="-122"/>
                 <a:cs typeface="Arial" pitchFamily="34" charset="-120"/>
               </a:rPr>
-              <a:t>Time-to-market elevato</a:t>
+              <a:t>High onboarding effort and engineering dependency constrain commercial flexibility, require long commitments, and reduce the attractiveness of smaller deals.</a:t>
             </a:r>
             <a:endParaRPr lang="en-US" sz="850" dirty="0"/>
           </a:p>
@@ -27697,7 +27697,7 @@
                 <a:ea typeface="Arial" pitchFamily="34" charset="-122"/>
                 <a:cs typeface="Arial" pitchFamily="34" charset="-120"/>
               </a:rPr>
-              <a:t>Scarsa presenza sui canali digitali</a:t>
+              <a:t>The product experience is not yet aligned with modern SaaS buyer expectations, creating friction in demonstrations and undermining perceived value.</a:t>
             </a:r>
             <a:endParaRPr lang="en-US" sz="850" dirty="0"/>
           </a:p>
@@ -27908,7 +27908,7 @@
                 <a:ea typeface="Arial" pitchFamily="34" charset="-122"/>
                 <a:cs typeface="Arial" pitchFamily="34" charset="-120"/>
               </a:rPr>
-              <a:t>Crescita del mercato cloud in EMEA</a:t>
+              <a:t>NUO can expand coverage quickly by building a virtual NUO sales team of selected internal reps with stronger incentives, enablement, and dotted-line accountability.</a:t>
             </a:r>
             <a:endParaRPr lang="en-US" sz="850" dirty="0"/>
           </a:p>
@@ -27991,7 +27991,7 @@
                 <a:ea typeface="Arial" pitchFamily="34" charset="-122"/>
                 <a:cs typeface="Arial" pitchFamily="34" charset="-120"/>
               </a:rPr>
-              <a:t>Nuovi segmenti SMB non ancora presidiati</a:t>
+              <a:t>Clarifying the relationship between NUO and Asset Management can turn internal conflict into a portfolio advantage through explicit DIY, outsourced, and hybrid commercial pathways.</a:t>
             </a:r>
             <a:endParaRPr lang="en-US" sz="850" dirty="0"/>
           </a:p>
@@ -28074,7 +28074,7 @@
                 <a:ea typeface="Arial" pitchFamily="34" charset="-122"/>
                 <a:cs typeface="Arial" pitchFamily="34" charset="-120"/>
               </a:rPr>
-              <a:t>Partnership con system integrator</a:t>
+              <a:t>A stricter ICP and qualification model can focus resources on portfolios with sufficient scale, urgency, data readiness, and multi-year commitment potential.</a:t>
             </a:r>
             <a:endParaRPr lang="en-US" sz="850" dirty="0"/>
           </a:p>
@@ -28157,7 +28157,7 @@
                 <a:ea typeface="Arial" pitchFamily="34" charset="-122"/>
                 <a:cs typeface="Arial" pitchFamily="34" charset="-120"/>
               </a:rPr>
-              <a:t>Espansione geografica nel mercato DACH</a:t>
+              <a:t>Standardizing onboarding through templates, automation, and tiered implementation packages would improve unit economics, shorten time-to-value, and potentially create room for more flexible commercial terms.</a:t>
             </a:r>
             <a:endParaRPr lang="en-US" sz="850" dirty="0"/>
           </a:p>
@@ -28368,7 +28368,7 @@
                 <a:ea typeface="Arial" pitchFamily="34" charset="-122"/>
                 <a:cs typeface="Arial" pitchFamily="34" charset="-120"/>
               </a:rPr>
-              <a:t>Ingresso di nuovi competitor low-cost</a:t>
+              <a:t>More mature SaaS competitors may win on modern UX, implementation confidence, roadmap velocity, and perceived platform credibility.</a:t>
             </a:r>
             <a:endParaRPr lang="en-US" sz="850" dirty="0"/>
           </a:p>
@@ -28451,7 +28451,7 @@
                 <a:ea typeface="Arial" pitchFamily="34" charset="-122"/>
                 <a:cs typeface="Arial" pitchFamily="34" charset="-120"/>
               </a:rPr>
-              <a:t>Evoluzione normativa GDPR e AI Act</a:t>
+              <a:t>Rising buyer expectations for cybersecurity, modern SaaS standards, and technical reliability could turn current product debt into a disqualifying purchase barrier.</a:t>
             </a:r>
             <a:endParaRPr lang="en-US" sz="850" dirty="0"/>
           </a:p>
@@ -28534,7 +28534,7 @@
                 <a:ea typeface="Arial" pitchFamily="34" charset="-122"/>
                 <a:cs typeface="Arial" pitchFamily="34" charset="-120"/>
               </a:rPr>
-              <a:t>Pressione sui margini da parte dei clienti</a:t>
+              <a:t>Internal portfolio conflict with Vector Asset Management may continue to dilute market focus and create confusing buyer messages if incentives and positioning remain unresolved.</a:t>
             </a:r>
             <a:endParaRPr lang="en-US" sz="850" dirty="0"/>
           </a:p>
@@ -28617,7 +28617,7 @@
                 <a:ea typeface="Arial" pitchFamily="34" charset="-122"/>
                 <a:cs typeface="Arial" pitchFamily="34" charset="-120"/>
               </a:rPr>
-              <a:t>Volatilità dei costi delle materie prime</a:t>
+              <a:t>Long and variable sales cycles expose NUO to budget changes, shifting buyer priorities, stakeholder turnover, and competitor displacement.</a:t>
             </a:r>
             <a:endParaRPr lang="en-US" sz="850" dirty="0"/>
           </a:p>
@@ -28717,7 +28717,7 @@
                   <a:srgbClr val="000000"/>
                 </a:solidFill>
               </a:rPr>
-              <a:t>© Value Accelerator GmbH | 29 Aprile 2026 | 1.0</a:t>
+              <a:t>© Value Accelerator GmbH |  | 1.0</a:t>
             </a:r>
             <a:r>
               <a:rPr lang="en-US" noProof="1">
@@ -29134,7 +29134,7 @@
                 <a:ea typeface="Arial" pitchFamily="34" charset="-122"/>
                 <a:cs typeface="Arial" pitchFamily="34" charset="-120"/>
               </a:rPr>
-              <a:t>La forza vendita è strutturata con ruoli hunter e farmer distinti.</a:t>
+              <a:t>NUO can expand coverage quickly by building a virtual NUO sales team of selected internal reps with stronger incentives, enablement, and dotted-line accountability.</a:t>
             </a:r>
             <a:endParaRPr lang="en-US" sz="850" dirty="0"/>
           </a:p>
@@ -29255,7 +29255,7 @@
                 <a:ea typeface="Arial" pitchFamily="34" charset="-122"/>
                 <a:cs typeface="Arial" pitchFamily="34" charset="-120"/>
               </a:rPr>
-              <a:t>Il processo di vendita è documentato e seguito con costanza.</a:t>
+              <a:t>A stricter ICP and qualification model can focus sales resources on portfolios with sufficient scale, urgency, data readiness, and multi-year commitment potential.</a:t>
             </a:r>
             <a:endParaRPr lang="en-US" sz="850" dirty="0"/>
           </a:p>
@@ -29376,7 +29376,7 @@
                 <a:ea typeface="Arial" pitchFamily="34" charset="-122"/>
                 <a:cs typeface="Arial" pitchFamily="34" charset="-120"/>
               </a:rPr>
-              <a:t>Il tasso di rinnovo contratti è superiore al 90%.</a:t>
+              <a:t>NUO already has a structured sales process with qualification, staged demos, technical validation, tailored offers, and trial-based risk reduction that can be codified for additional sellers.</a:t>
             </a:r>
             <a:endParaRPr lang="en-US" sz="850" dirty="0"/>
           </a:p>
@@ -29497,7 +29497,7 @@
                 <a:ea typeface="Arial" pitchFamily="34" charset="-122"/>
                 <a:cs typeface="Arial" pitchFamily="34" charset="-120"/>
               </a:rPr>
-              <a:t>Esiste un programma di incentivazione efficace per il team sales.</a:t>
+              <a:t/>
             </a:r>
             <a:endParaRPr lang="en-US" sz="850" dirty="0"/>
           </a:p>
@@ -29618,7 +29618,7 @@
                 <a:ea typeface="Arial" pitchFamily="34" charset="-122"/>
                 <a:cs typeface="Arial" pitchFamily="34" charset="-120"/>
               </a:rPr>
-              <a:t>Il CRM è adottato da tutto il team con dati aggiornati.</a:t>
+              <a:t/>
             </a:r>
             <a:endParaRPr lang="en-US" sz="850" dirty="0"/>
           </a:p>
@@ -29739,7 +29739,7 @@
                 <a:ea typeface="Arial" pitchFamily="34" charset="-122"/>
                 <a:cs typeface="Arial" pitchFamily="34" charset="-120"/>
               </a:rPr>
-              <a:t>Le previsioni di vendita hanno un'accuratezza superiore all'80%.</a:t>
+              <a:t/>
             </a:r>
             <a:endParaRPr lang="en-US" sz="850" dirty="0"/>
           </a:p>
@@ -29860,7 +29860,7 @@
                 <a:ea typeface="Arial" pitchFamily="34" charset="-122"/>
                 <a:cs typeface="Arial" pitchFamily="34" charset="-120"/>
               </a:rPr>
-              <a:t>Il processo di onboarding nuovi clienti è strutturato.</a:t>
+              <a:t/>
             </a:r>
             <a:endParaRPr lang="en-US" sz="850" dirty="0"/>
           </a:p>
@@ -29981,7 +29981,7 @@
                 <a:ea typeface="Arial" pitchFamily="34" charset="-122"/>
                 <a:cs typeface="Arial" pitchFamily="34" charset="-120"/>
               </a:rPr>
-              <a:t>Esistono partnership di canale attive con rivenditori qualificati.</a:t>
+              <a:t/>
             </a:r>
             <a:endParaRPr lang="en-US" sz="850" dirty="0"/>
           </a:p>
@@ -30102,7 +30102,7 @@
                 <a:ea typeface="Arial" pitchFamily="34" charset="-122"/>
                 <a:cs typeface="Arial" pitchFamily="34" charset="-120"/>
               </a:rPr>
-              <a:t>Il ciclo medio di vendita si è ridotto del 20% nell'ultimo anno.</a:t>
+              <a:t/>
             </a:r>
             <a:endParaRPr lang="en-US" sz="850" dirty="0"/>
           </a:p>
@@ -30348,7 +30348,7 @@
                 <a:ea typeface="Arial" pitchFamily="34" charset="-122"/>
                 <a:cs typeface="Arial" pitchFamily="34" charset="-120"/>
               </a:rPr>
-              <a:t>La pipeline non è sufficientemente diversificata per settore verticale.</a:t>
+              <a:t>The one-person global sales model prevents sufficient market coverage and makes revenue generation fragile.</a:t>
             </a:r>
             <a:endParaRPr lang="en-US" sz="850" dirty="0"/>
           </a:p>
@@ -30469,7 +30469,7 @@
                 <a:ea typeface="Arial" pitchFamily="34" charset="-122"/>
                 <a:cs typeface="Arial" pitchFamily="34" charset="-120"/>
               </a:rPr>
-              <a:t>Manca un processo formalizzato di win/loss analysis.</a:t>
+              <a:t>High onboarding effort and engineering dependency constrain commercial flexibility, require long commitments, and reduce the attractiveness of smaller deals.</a:t>
             </a:r>
             <a:endParaRPr lang="en-US" sz="850" dirty="0"/>
           </a:p>
@@ -30590,7 +30590,7 @@
                 <a:ea typeface="Arial" pitchFamily="34" charset="-122"/>
                 <a:cs typeface="Arial" pitchFamily="34" charset="-120"/>
               </a:rPr>
-              <a:t>Il time-to-quote è ancora troppo elevato per offerte complesse.</a:t>
+              <a:t>Internal incentives and positioning between NUO and Vector Asset Management are misaligned, reducing cross-sell motivation and creating potential cannibalization concerns.</a:t>
             </a:r>
             <a:endParaRPr lang="en-US" sz="850" dirty="0"/>
           </a:p>
@@ -30696,7 +30696,7 @@
                   <a:srgbClr val="000000"/>
                 </a:solidFill>
               </a:rPr>
-              <a:t>© Value Accelerator GmbH | 29 Aprile 2026 | 1.0</a:t>
+              <a:t>© Value Accelerator GmbH |  | 1.0</a:t>
             </a:r>
             <a:r>
               <a:rPr lang="en-US" noProof="1">
@@ -31113,7 +31113,7 @@
                 <a:ea typeface="Arial" pitchFamily="34" charset="-122"/>
                 <a:cs typeface="Arial" pitchFamily="34" charset="-120"/>
               </a:rPr>
-              <a:t>Il brand è ben posizionato nel segmento enterprise.</a:t>
+              <a:t>A more modern demand-generation program can create qualified inbound pipeline and reduce dependence on one seller’s prospecting capacity.</a:t>
             </a:r>
             <a:endParaRPr lang="en-US" sz="850" dirty="0"/>
           </a:p>
@@ -31234,7 +31234,7 @@
                 <a:ea typeface="Arial" pitchFamily="34" charset="-122"/>
                 <a:cs typeface="Arial" pitchFamily="34" charset="-120"/>
               </a:rPr>
-              <a:t>La content strategy produce lead qualificati in modo costante.</a:t>
+              <a:t/>
             </a:r>
             <a:endParaRPr lang="en-US" sz="850" dirty="0"/>
           </a:p>
@@ -31355,7 +31355,7 @@
                 <a:ea typeface="Arial" pitchFamily="34" charset="-122"/>
                 <a:cs typeface="Arial" pitchFamily="34" charset="-120"/>
               </a:rPr>
-              <a:t>Il sito web è stato recentemente rinnovato con focus sulla UX.</a:t>
+              <a:t/>
             </a:r>
             <a:endParaRPr lang="en-US" sz="850" dirty="0"/>
           </a:p>
@@ -31476,7 +31476,7 @@
                 <a:ea typeface="Arial" pitchFamily="34" charset="-122"/>
                 <a:cs typeface="Arial" pitchFamily="34" charset="-120"/>
               </a:rPr>
-              <a:t>Sono attive campagne SEO/SEM con ROI misurabile.</a:t>
+              <a:t/>
             </a:r>
             <a:endParaRPr lang="en-US" sz="850" dirty="0"/>
           </a:p>
@@ -31597,7 +31597,7 @@
                 <a:ea typeface="Arial" pitchFamily="34" charset="-122"/>
                 <a:cs typeface="Arial" pitchFamily="34" charset="-120"/>
               </a:rPr>
-              <a:t>La presenza su LinkedIn è cresciuta del 30% nell'ultimo anno.</a:t>
+              <a:t/>
             </a:r>
             <a:endParaRPr lang="en-US" sz="850" dirty="0"/>
           </a:p>
@@ -31718,7 +31718,7 @@
                 <a:ea typeface="Arial" pitchFamily="34" charset="-122"/>
                 <a:cs typeface="Arial" pitchFamily="34" charset="-120"/>
               </a:rPr>
-              <a:t>Esiste un programma di referral clienti attivo.</a:t>
+              <a:t/>
             </a:r>
             <a:endParaRPr lang="en-US" sz="850" dirty="0"/>
           </a:p>
@@ -31839,7 +31839,7 @@
                 <a:ea typeface="Arial" pitchFamily="34" charset="-122"/>
                 <a:cs typeface="Arial" pitchFamily="34" charset="-120"/>
               </a:rPr>
-              <a:t>Il CRM è integrato con gli strumenti di marketing automation.</a:t>
+              <a:t/>
             </a:r>
             <a:endParaRPr lang="en-US" sz="850" dirty="0"/>
           </a:p>
@@ -31960,7 +31960,7 @@
                 <a:ea typeface="Arial" pitchFamily="34" charset="-122"/>
                 <a:cs typeface="Arial" pitchFamily="34" charset="-120"/>
               </a:rPr>
-              <a:t>Gli eventi di settore generano pipeline qualificata.</a:t>
+              <a:t/>
             </a:r>
             <a:endParaRPr lang="en-US" sz="850" dirty="0"/>
           </a:p>
@@ -32081,7 +32081,7 @@
                 <a:ea typeface="Arial" pitchFamily="34" charset="-122"/>
                 <a:cs typeface="Arial" pitchFamily="34" charset="-120"/>
               </a:rPr>
-              <a:t>Il team marketing è strutturato per specializzazione (demand, brand, digital).</a:t>
+              <a:t/>
             </a:r>
             <a:endParaRPr lang="en-US" sz="850" dirty="0"/>
           </a:p>
@@ -32327,7 +32327,7 @@
                 <a:ea typeface="Arial" pitchFamily="34" charset="-122"/>
                 <a:cs typeface="Arial" pitchFamily="34" charset="-120"/>
               </a:rPr>
-              <a:t>Il budget marketing è inferiore alla media del settore (&lt; 5% del fatturato).</a:t>
+              <a:t>Marketing lacks demand-generation rigor and differentiation, leaving sales under-supported and limiting inbound pipeline creation.</a:t>
             </a:r>
             <a:endParaRPr lang="en-US" sz="850" dirty="0"/>
           </a:p>
@@ -32448,7 +32448,7 @@
                 <a:ea typeface="Arial" pitchFamily="34" charset="-122"/>
                 <a:cs typeface="Arial" pitchFamily="34" charset="-120"/>
               </a:rPr>
-              <a:t>Manca una strategia organica sui canali video e social media.</a:t>
+              <a:t/>
             </a:r>
             <a:endParaRPr lang="en-US" sz="850" dirty="0"/>
           </a:p>
@@ -32569,7 +32569,7 @@
                 <a:ea typeface="Arial" pitchFamily="34" charset="-122"/>
                 <a:cs typeface="Arial" pitchFamily="34" charset="-120"/>
               </a:rPr>
-              <a:t>Le campagne outbound hanno tassi di conversione in calo.</a:t>
+              <a:t/>
             </a:r>
             <a:endParaRPr lang="en-US" sz="850" dirty="0"/>
           </a:p>
@@ -32675,7 +32675,7 @@
                   <a:srgbClr val="000000"/>
                 </a:solidFill>
               </a:rPr>
-              <a:t>© Value Accelerator GmbH | 29 Aprile 2026 | 1.0</a:t>
+              <a:t>© Value Accelerator GmbH |  | 1.0</a:t>
             </a:r>
             <a:r>
               <a:rPr lang="en-US" noProof="1">
@@ -33092,7 +33092,7 @@
                 <a:ea typeface="Arial" pitchFamily="34" charset="-122"/>
                 <a:cs typeface="Arial" pitchFamily="34" charset="-120"/>
               </a:rPr>
-              <a:t>La roadmap di prodotto è definita su 18 mesi con priorità chiare.</a:t>
+              <a:t>Standardizing onboarding through templates, automation, and tiered implementation packages would improve unit economics, shorten time-to-value, and potentially create room for more flexible commercial terms.</a:t>
             </a:r>
             <a:endParaRPr lang="en-US" sz="850" dirty="0"/>
           </a:p>
@@ -33213,7 +33213,7 @@
                 <a:ea typeface="Arial" pitchFamily="34" charset="-122"/>
                 <a:cs typeface="Arial" pitchFamily="34" charset="-120"/>
               </a:rPr>
-              <a:t>Il processo di sviluppo agile è maturo e ben adottato.</a:t>
+              <a:t>Modernizing the product experience and publishing a credible roadmap would reduce sales friction and strengthen NUO’s ability to compete as a SaaS platform rather than a bespoke internal tool.</a:t>
             </a:r>
             <a:endParaRPr lang="en-US" sz="850" dirty="0"/>
           </a:p>
@@ -33334,7 +33334,7 @@
                 <a:ea typeface="Arial" pitchFamily="34" charset="-122"/>
                 <a:cs typeface="Arial" pitchFamily="34" charset="-120"/>
               </a:rPr>
-              <a:t>La qualità del prodotto è certificata ISO 9001.</a:t>
+              <a:t>NUO can combine executive-level selling with technical validation by involving Customer Success in deeper product evaluations.</a:t>
             </a:r>
             <a:endParaRPr lang="en-US" sz="850" dirty="0"/>
           </a:p>
@@ -33455,7 +33455,7 @@
                 <a:ea typeface="Arial" pitchFamily="34" charset="-122"/>
                 <a:cs typeface="Arial" pitchFamily="34" charset="-120"/>
               </a:rPr>
-              <a:t>Il feedback dei clienti è sistematicamente raccolto e analizzato.</a:t>
+              <a:t/>
             </a:r>
             <a:endParaRPr lang="en-US" sz="850" dirty="0"/>
           </a:p>
@@ -33576,7 +33576,7 @@
                 <a:ea typeface="Arial" pitchFamily="34" charset="-122"/>
                 <a:cs typeface="Arial" pitchFamily="34" charset="-120"/>
               </a:rPr>
-              <a:t>Esiste un team dedicato alla UX/UI con competenze solide.</a:t>
+              <a:t/>
             </a:r>
             <a:endParaRPr lang="en-US" sz="850" dirty="0"/>
           </a:p>
@@ -33697,7 +33697,7 @@
                 <a:ea typeface="Arial" pitchFamily="34" charset="-122"/>
                 <a:cs typeface="Arial" pitchFamily="34" charset="-120"/>
               </a:rPr>
-              <a:t>L'architettura tecnologica è moderna e scalabile (cloud-native).</a:t>
+              <a:t/>
             </a:r>
             <a:endParaRPr lang="en-US" sz="850" dirty="0"/>
           </a:p>
@@ -33818,7 +33818,7 @@
                 <a:ea typeface="Arial" pitchFamily="34" charset="-122"/>
                 <a:cs typeface="Arial" pitchFamily="34" charset="-120"/>
               </a:rPr>
-              <a:t>La sicurezza del prodotto è presidiata con vulnerability assessment periodici.</a:t>
+              <a:t/>
             </a:r>
             <a:endParaRPr lang="en-US" sz="850" dirty="0"/>
           </a:p>
@@ -33939,7 +33939,7 @@
                 <a:ea typeface="Arial" pitchFamily="34" charset="-122"/>
                 <a:cs typeface="Arial" pitchFamily="34" charset="-120"/>
               </a:rPr>
-              <a:t>Le integrazioni con sistemi terzi sono documentate e stabili.</a:t>
+              <a:t/>
             </a:r>
             <a:endParaRPr lang="en-US" sz="850" dirty="0"/>
           </a:p>
@@ -34060,7 +34060,7 @@
                 <a:ea typeface="Arial" pitchFamily="34" charset="-122"/>
                 <a:cs typeface="Arial" pitchFamily="34" charset="-120"/>
               </a:rPr>
-              <a:t>Il time-to-market per nuove feature è in miglioramento costante.</a:t>
+              <a:t/>
             </a:r>
             <a:endParaRPr lang="en-US" sz="850" dirty="0"/>
           </a:p>
@@ -34306,7 +34306,7 @@
                 <a:ea typeface="Arial" pitchFamily="34" charset="-122"/>
                 <a:cs typeface="Arial" pitchFamily="34" charset="-120"/>
               </a:rPr>
-              <a:t>Il debito tecnico accumulato rallenta lo sviluppo di nuove funzionalità.</a:t>
+              <a:t>More mature SaaS competitors may win on modern UX, implementation confidence, roadmap velocity, and perceived platform credibility.</a:t>
             </a:r>
             <a:endParaRPr lang="en-US" sz="850" dirty="0"/>
           </a:p>
@@ -34427,7 +34427,7 @@
                 <a:ea typeface="Arial" pitchFamily="34" charset="-122"/>
                 <a:cs typeface="Arial" pitchFamily="34" charset="-120"/>
               </a:rPr>
-              <a:t>Manca una strategia chiara per l'adozione dell'AI nel prodotto.</a:t>
+              <a:t>Rising buyer expectations for cybersecurity, modern SaaS standards, and technical reliability could turn current product debt into a disqualifying purchase barrier.</a:t>
             </a:r>
             <a:endParaRPr lang="en-US" sz="850" dirty="0"/>
           </a:p>
@@ -34548,7 +34548,7 @@
                 <a:ea typeface="Arial" pitchFamily="34" charset="-122"/>
                 <a:cs typeface="Arial" pitchFamily="34" charset="-120"/>
               </a:rPr>
-              <a:t>La documentazione tecnica non è sempre aggiornata.</a:t>
+              <a:t>Product development appears reactive and client-funded rather than roadmap-led, which risks creating a bespoke-services perception and slowing scalable product maturation.</a:t>
             </a:r>
             <a:endParaRPr lang="en-US" sz="850" dirty="0"/>
           </a:p>
@@ -34654,7 +34654,7 @@
                   <a:srgbClr val="000000"/>
                 </a:solidFill>
               </a:rPr>
-              <a:t>© Value Accelerator GmbH | 29 Aprile 2026 | 1.0</a:t>
+              <a:t>© Value Accelerator GmbH |  | 1.0</a:t>
             </a:r>
             <a:r>
               <a:rPr lang="en-US" noProof="1">
@@ -35071,7 +35071,7 @@
                 <a:ea typeface="Arial" pitchFamily="34" charset="-122"/>
                 <a:cs typeface="Arial" pitchFamily="34" charset="-120"/>
               </a:rPr>
-              <a:t>La visione strategica è chiaramente definita e condivisa dal top management.</a:t>
+              <a:t>NUO can expand coverage quickly by building a virtual NUO sales team of selected internal reps with stronger incentives, enablement, and dotted-line accountability.</a:t>
             </a:r>
             <a:endParaRPr lang="en-US" sz="850" dirty="0"/>
           </a:p>
@@ -35192,7 +35192,7 @@
                 <a:ea typeface="Arial" pitchFamily="34" charset="-122"/>
                 <a:cs typeface="Arial" pitchFamily="34" charset="-120"/>
               </a:rPr>
-              <a:t>Esiste un piano triennale aggiornato con obiettivi misurabili.</a:t>
+              <a:t>Clarifying the relationship between NUO and Asset Management can turn internal conflict into a portfolio advantage through explicit DIY, outsourced, and hybrid commercial pathways.</a:t>
             </a:r>
             <a:endParaRPr lang="en-US" sz="850" dirty="0"/>
           </a:p>
@@ -35313,7 +35313,7 @@
                 <a:ea typeface="Arial" pitchFamily="34" charset="-122"/>
                 <a:cs typeface="Arial" pitchFamily="34" charset="-120"/>
               </a:rPr>
-              <a:t>Il budget R&amp;D è in crescita del 15% rispetto all'anno precedente.</a:t>
+              <a:t>A stricter ICP and qualification model can focus resources on portfolios with sufficient scale, urgency, data readiness, and multi-year commitment potential.</a:t>
             </a:r>
             <a:endParaRPr lang="en-US" sz="850" dirty="0"/>
           </a:p>
@@ -35434,7 +35434,7 @@
                 <a:ea typeface="Arial" pitchFamily="34" charset="-122"/>
                 <a:cs typeface="Arial" pitchFamily="34" charset="-120"/>
               </a:rPr>
-              <a:t>La governance è strutturata con board attivo e comitati funzionanti.</a:t>
+              <a:t/>
             </a:r>
             <a:endParaRPr lang="en-US" sz="850" dirty="0"/>
           </a:p>
@@ -35555,7 +35555,7 @@
                 <a:ea typeface="Arial" pitchFamily="34" charset="-122"/>
                 <a:cs typeface="Arial" pitchFamily="34" charset="-120"/>
               </a:rPr>
-              <a:t>Le iniziative di trasformazione digitale sono presidiate da un CDO dedicato.</a:t>
+              <a:t/>
             </a:r>
             <a:endParaRPr lang="en-US" sz="850" dirty="0"/>
           </a:p>
@@ -35676,7 +35676,7 @@
                 <a:ea typeface="Arial" pitchFamily="34" charset="-122"/>
                 <a:cs typeface="Arial" pitchFamily="34" charset="-120"/>
               </a:rPr>
-              <a:t>Il processo di pianificazione coinvolge tutte le business unit.</a:t>
+              <a:t/>
             </a:r>
             <a:endParaRPr lang="en-US" sz="850" dirty="0"/>
           </a:p>
@@ -35797,7 +35797,7 @@
                 <a:ea typeface="Arial" pitchFamily="34" charset="-122"/>
                 <a:cs typeface="Arial" pitchFamily="34" charset="-120"/>
               </a:rPr>
-              <a:t>Sono presenti KPI strategici monitorati trimestralmente.</a:t>
+              <a:t/>
             </a:r>
             <a:endParaRPr lang="en-US" sz="850" dirty="0"/>
           </a:p>
@@ -35918,7 +35918,7 @@
                 <a:ea typeface="Arial" pitchFamily="34" charset="-122"/>
                 <a:cs typeface="Arial" pitchFamily="34" charset="-120"/>
               </a:rPr>
-              <a:t>La cultura aziendale supporta l'innovazione e il cambiamento.</a:t>
+              <a:t/>
             </a:r>
             <a:endParaRPr lang="en-US" sz="850" dirty="0"/>
           </a:p>
@@ -36039,7 +36039,7 @@
                 <a:ea typeface="Arial" pitchFamily="34" charset="-122"/>
                 <a:cs typeface="Arial" pitchFamily="34" charset="-120"/>
               </a:rPr>
-              <a:t>Esistono programmi strutturati di sviluppo del talento interno.</a:t>
+              <a:t/>
             </a:r>
             <a:endParaRPr lang="en-US" sz="850" dirty="0"/>
           </a:p>
@@ -36285,7 +36285,7 @@
                 <a:ea typeface="Arial" pitchFamily="34" charset="-122"/>
                 <a:cs typeface="Arial" pitchFamily="34" charset="-120"/>
               </a:rPr>
-              <a:t>La strategia di internazionalizzazione non è ancora operativa.</a:t>
+              <a:t>The one-person global sales model prevents sufficient market coverage and makes revenue generation fragile.</a:t>
             </a:r>
             <a:endParaRPr lang="en-US" sz="850" dirty="0"/>
           </a:p>
@@ -36406,7 +36406,7 @@
                 <a:ea typeface="Arial" pitchFamily="34" charset="-122"/>
                 <a:cs typeface="Arial" pitchFamily="34" charset="-120"/>
               </a:rPr>
-              <a:t>Mancano strumenti di scenario planning a medio-lungo termine.</a:t>
+              <a:t>Internal portfolio conflict with Vector Asset Management may continue to dilute market focus and create confusing buyer messages if incentives and positioning remain unresolved.</a:t>
             </a:r>
             <a:endParaRPr lang="en-US" sz="850" dirty="0"/>
           </a:p>
@@ -36527,7 +36527,7 @@
                 <a:ea typeface="Arial" pitchFamily="34" charset="-122"/>
                 <a:cs typeface="Arial" pitchFamily="34" charset="-120"/>
               </a:rPr>
-              <a:t>Il processo di M&amp;A non è presidiato da competenze dedicate.</a:t>
+              <a:t>Long and variable sales cycles expose NUO to budget changes, shifting buyer priorities, stakeholder turnover, and competitor displacement.</a:t>
             </a:r>
             <a:endParaRPr lang="en-US" sz="850" dirty="0"/>
           </a:p>
@@ -36633,7 +36633,7 @@
                   <a:srgbClr val="000000"/>
                 </a:solidFill>
               </a:rPr>
-              <a:t>© Value Accelerator GmbH | 29 Aprile 2026 | 1.0</a:t>
+              <a:t>© Value Accelerator GmbH |  | 1.0</a:t>
             </a:r>
             <a:r>
               <a:rPr lang="en-US" noProof="1">
@@ -38724,7 +38724,7 @@
                   <a:srgbClr val="000000"/>
                 </a:solidFill>
               </a:rPr>
-              <a:t>© Value Accelerator GmbH | 29 Aprile 2026 | 1.0</a:t>
+              <a:t>© Value Accelerator GmbH |  | 1.0</a:t>
             </a:r>
             <a:r>
               <a:rPr lang="en-US" noProof="1">

</xml_diff>